<commit_message>
Refactor configuration files and enhance folder management
- Updated `batch_kling_effects_config.yaml` to change task grouping and base folder paths, and added new effects for processing.
- Modified `batch_pixverse_config.yaml` to change the base folder and update effect details.
- Enhanced `nano_multi_generation.yaml` with stricter face ID requirements and detailed prompts for image generation.
- Revised `nano_new_year.yaml` to adjust task prompts, aspect ratios, and added new tasks with strict identity preservation rules.
- Improved `unified_api_processor.py` to auto-create necessary directories for tasks and log warnings for missing images.
- Updated `base_handler.py` to ensure output and metadata folders are created before processing tasks.
- Changed binary `I2V templates.pptx` file, indicating updates to the template used for presentations.
</commit_message>
<xml_diff>
--- a/Scripts/templates/I2V templates.pptx
+++ b/Scripts/templates/I2V templates.pptx
@@ -200,7 +200,7 @@
           <a:p>
             <a:fld id="{B5D6417E-267F-B340-921F-2BE1F4386BD8}" type="datetimeFigureOut">
               <a:rPr lang="en-TW" smtClean="0"/>
-              <a:t>2025/10/17</a:t>
+              <a:t>2026/1/27</a:t>
             </a:fld>
             <a:endParaRPr lang="en-TW"/>
           </a:p>
@@ -617,7 +617,7 @@
           <a:p>
             <a:fld id="{1B18B556-6596-E04A-9A94-BF47DB4EF23C}" type="datetimeFigureOut">
               <a:rPr lang="en-TW" smtClean="0"/>
-              <a:t>2025/10/17</a:t>
+              <a:t>2026/1/27</a:t>
             </a:fld>
             <a:endParaRPr lang="en-TW"/>
           </a:p>
@@ -930,7 +930,7 @@
           <a:p>
             <a:fld id="{1B18B556-6596-E04A-9A94-BF47DB4EF23C}" type="datetimeFigureOut">
               <a:rPr lang="en-TW" smtClean="0"/>
-              <a:t>2025/10/17</a:t>
+              <a:t>2026/1/27</a:t>
             </a:fld>
             <a:endParaRPr lang="en-TW"/>
           </a:p>
@@ -1223,7 +1223,7 @@
           <a:p>
             <a:fld id="{1B18B556-6596-E04A-9A94-BF47DB4EF23C}" type="datetimeFigureOut">
               <a:rPr lang="en-TW" smtClean="0"/>
-              <a:t>2025/10/17</a:t>
+              <a:t>2026/1/27</a:t>
             </a:fld>
             <a:endParaRPr lang="en-TW"/>
           </a:p>
@@ -1423,7 +1423,7 @@
           <a:p>
             <a:fld id="{1B18B556-6596-E04A-9A94-BF47DB4EF23C}" type="datetimeFigureOut">
               <a:rPr lang="en-TW" smtClean="0"/>
-              <a:t>2025/10/17</a:t>
+              <a:t>2026/1/27</a:t>
             </a:fld>
             <a:endParaRPr lang="en-TW"/>
           </a:p>
@@ -1633,7 +1633,7 @@
           <a:p>
             <a:fld id="{1B18B556-6596-E04A-9A94-BF47DB4EF23C}" type="datetimeFigureOut">
               <a:rPr lang="en-TW" smtClean="0"/>
-              <a:t>2025/10/17</a:t>
+              <a:t>2026/1/27</a:t>
             </a:fld>
             <a:endParaRPr lang="en-TW"/>
           </a:p>
@@ -1833,7 +1833,7 @@
           <a:p>
             <a:fld id="{1B18B556-6596-E04A-9A94-BF47DB4EF23C}" type="datetimeFigureOut">
               <a:rPr lang="en-TW" smtClean="0"/>
-              <a:t>2025/10/17</a:t>
+              <a:t>2026/1/27</a:t>
             </a:fld>
             <a:endParaRPr lang="en-TW"/>
           </a:p>
@@ -2109,7 +2109,7 @@
           <a:p>
             <a:fld id="{1B18B556-6596-E04A-9A94-BF47DB4EF23C}" type="datetimeFigureOut">
               <a:rPr lang="en-TW" smtClean="0"/>
-              <a:t>2025/10/17</a:t>
+              <a:t>2026/1/27</a:t>
             </a:fld>
             <a:endParaRPr lang="en-TW"/>
           </a:p>
@@ -2377,7 +2377,7 @@
           <a:p>
             <a:fld id="{1B18B556-6596-E04A-9A94-BF47DB4EF23C}" type="datetimeFigureOut">
               <a:rPr lang="en-TW" smtClean="0"/>
-              <a:t>2025/10/17</a:t>
+              <a:t>2026/1/27</a:t>
             </a:fld>
             <a:endParaRPr lang="en-TW"/>
           </a:p>
@@ -2792,7 +2792,7 @@
           <a:p>
             <a:fld id="{1B18B556-6596-E04A-9A94-BF47DB4EF23C}" type="datetimeFigureOut">
               <a:rPr lang="en-TW" smtClean="0"/>
-              <a:t>2025/10/17</a:t>
+              <a:t>2026/1/27</a:t>
             </a:fld>
             <a:endParaRPr lang="en-TW"/>
           </a:p>
@@ -2934,7 +2934,7 @@
           <a:p>
             <a:fld id="{1B18B556-6596-E04A-9A94-BF47DB4EF23C}" type="datetimeFigureOut">
               <a:rPr lang="en-TW" smtClean="0"/>
-              <a:t>2025/10/17</a:t>
+              <a:t>2026/1/27</a:t>
             </a:fld>
             <a:endParaRPr lang="en-TW"/>
           </a:p>
@@ -3247,7 +3247,7 @@
             <a:pPr algn="ctr"/>
             <a:r>
               <a:rPr lang="en-TW" dirty="0"/>
-              <a:t>Video</a:t>
+              <a:t>Gen</a:t>
             </a:r>
           </a:p>
         </p:txBody>
@@ -3776,7 +3776,7 @@
           <a:p>
             <a:fld id="{1B18B556-6596-E04A-9A94-BF47DB4EF23C}" type="datetimeFigureOut">
               <a:rPr lang="en-TW" smtClean="0"/>
-              <a:t>2025/10/17</a:t>
+              <a:t>2026/1/27</a:t>
             </a:fld>
             <a:endParaRPr lang="en-TW"/>
           </a:p>
@@ -4019,7 +4019,7 @@
           <a:p>
             <a:fld id="{1B18B556-6596-E04A-9A94-BF47DB4EF23C}" type="datetimeFigureOut">
               <a:rPr lang="en-TW" smtClean="0"/>
-              <a:t>2025/10/17</a:t>
+              <a:t>2026/1/27</a:t>
             </a:fld>
             <a:endParaRPr lang="en-TW"/>
           </a:p>

</xml_diff>

<commit_message>
chore: Update I2V templates.pptx with new content
</commit_message>
<xml_diff>
--- a/Scripts/templates/I2V templates.pptx
+++ b/Scripts/templates/I2V templates.pptx
@@ -200,7 +200,7 @@
           <a:p>
             <a:fld id="{B5D6417E-267F-B340-921F-2BE1F4386BD8}" type="datetimeFigureOut">
               <a:rPr lang="en-TW" smtClean="0"/>
-              <a:t>2026/1/27</a:t>
+              <a:t>2026/2/5</a:t>
             </a:fld>
             <a:endParaRPr lang="en-TW"/>
           </a:p>
@@ -617,7 +617,7 @@
           <a:p>
             <a:fld id="{1B18B556-6596-E04A-9A94-BF47DB4EF23C}" type="datetimeFigureOut">
               <a:rPr lang="en-TW" smtClean="0"/>
-              <a:t>2026/1/27</a:t>
+              <a:t>2026/2/5</a:t>
             </a:fld>
             <a:endParaRPr lang="en-TW"/>
           </a:p>
@@ -930,7 +930,7 @@
           <a:p>
             <a:fld id="{1B18B556-6596-E04A-9A94-BF47DB4EF23C}" type="datetimeFigureOut">
               <a:rPr lang="en-TW" smtClean="0"/>
-              <a:t>2026/1/27</a:t>
+              <a:t>2026/2/5</a:t>
             </a:fld>
             <a:endParaRPr lang="en-TW"/>
           </a:p>
@@ -1223,7 +1223,7 @@
           <a:p>
             <a:fld id="{1B18B556-6596-E04A-9A94-BF47DB4EF23C}" type="datetimeFigureOut">
               <a:rPr lang="en-TW" smtClean="0"/>
-              <a:t>2026/1/27</a:t>
+              <a:t>2026/2/5</a:t>
             </a:fld>
             <a:endParaRPr lang="en-TW"/>
           </a:p>
@@ -1423,7 +1423,7 @@
           <a:p>
             <a:fld id="{1B18B556-6596-E04A-9A94-BF47DB4EF23C}" type="datetimeFigureOut">
               <a:rPr lang="en-TW" smtClean="0"/>
-              <a:t>2026/1/27</a:t>
+              <a:t>2026/2/5</a:t>
             </a:fld>
             <a:endParaRPr lang="en-TW"/>
           </a:p>
@@ -1633,7 +1633,7 @@
           <a:p>
             <a:fld id="{1B18B556-6596-E04A-9A94-BF47DB4EF23C}" type="datetimeFigureOut">
               <a:rPr lang="en-TW" smtClean="0"/>
-              <a:t>2026/1/27</a:t>
+              <a:t>2026/2/5</a:t>
             </a:fld>
             <a:endParaRPr lang="en-TW"/>
           </a:p>
@@ -1833,7 +1833,7 @@
           <a:p>
             <a:fld id="{1B18B556-6596-E04A-9A94-BF47DB4EF23C}" type="datetimeFigureOut">
               <a:rPr lang="en-TW" smtClean="0"/>
-              <a:t>2026/1/27</a:t>
+              <a:t>2026/2/5</a:t>
             </a:fld>
             <a:endParaRPr lang="en-TW"/>
           </a:p>
@@ -2109,7 +2109,7 @@
           <a:p>
             <a:fld id="{1B18B556-6596-E04A-9A94-BF47DB4EF23C}" type="datetimeFigureOut">
               <a:rPr lang="en-TW" smtClean="0"/>
-              <a:t>2026/1/27</a:t>
+              <a:t>2026/2/5</a:t>
             </a:fld>
             <a:endParaRPr lang="en-TW"/>
           </a:p>
@@ -2377,7 +2377,7 @@
           <a:p>
             <a:fld id="{1B18B556-6596-E04A-9A94-BF47DB4EF23C}" type="datetimeFigureOut">
               <a:rPr lang="en-TW" smtClean="0"/>
-              <a:t>2026/1/27</a:t>
+              <a:t>2026/2/5</a:t>
             </a:fld>
             <a:endParaRPr lang="en-TW"/>
           </a:p>
@@ -2792,7 +2792,7 @@
           <a:p>
             <a:fld id="{1B18B556-6596-E04A-9A94-BF47DB4EF23C}" type="datetimeFigureOut">
               <a:rPr lang="en-TW" smtClean="0"/>
-              <a:t>2026/1/27</a:t>
+              <a:t>2026/2/5</a:t>
             </a:fld>
             <a:endParaRPr lang="en-TW"/>
           </a:p>
@@ -2934,7 +2934,7 @@
           <a:p>
             <a:fld id="{1B18B556-6596-E04A-9A94-BF47DB4EF23C}" type="datetimeFigureOut">
               <a:rPr lang="en-TW" smtClean="0"/>
-              <a:t>2026/1/27</a:t>
+              <a:t>2026/2/5</a:t>
             </a:fld>
             <a:endParaRPr lang="en-TW"/>
           </a:p>
@@ -3048,39 +3048,70 @@
         </p:spPr>
         <p:txBody>
           <a:bodyPr/>
-          <a:lstStyle/>
+          <a:lstStyle>
+            <a:lvl1pPr>
+              <a:defRPr baseline="0">
+                <a:latin typeface="Arial" panose="020B0604020202020204" pitchFamily="34" charset="0"/>
+                <a:ea typeface="Microsoft JhengHei" panose="020B0604030504040204" pitchFamily="34" charset="-120"/>
+              </a:defRPr>
+            </a:lvl1pPr>
+            <a:lvl2pPr>
+              <a:defRPr baseline="0">
+                <a:latin typeface="Arial" panose="020B0604020202020204" pitchFamily="34" charset="0"/>
+                <a:ea typeface="Microsoft JhengHei" panose="020B0604030504040204" pitchFamily="34" charset="-120"/>
+              </a:defRPr>
+            </a:lvl2pPr>
+            <a:lvl3pPr>
+              <a:defRPr baseline="0">
+                <a:latin typeface="Arial" panose="020B0604020202020204" pitchFamily="34" charset="0"/>
+                <a:ea typeface="Microsoft JhengHei" panose="020B0604030504040204" pitchFamily="34" charset="-120"/>
+              </a:defRPr>
+            </a:lvl3pPr>
+            <a:lvl4pPr>
+              <a:defRPr baseline="0">
+                <a:latin typeface="Arial" panose="020B0604020202020204" pitchFamily="34" charset="0"/>
+                <a:ea typeface="Microsoft JhengHei" panose="020B0604030504040204" pitchFamily="34" charset="-120"/>
+              </a:defRPr>
+            </a:lvl4pPr>
+            <a:lvl5pPr>
+              <a:defRPr baseline="0">
+                <a:latin typeface="Arial" panose="020B0604020202020204" pitchFamily="34" charset="0"/>
+                <a:ea typeface="Microsoft JhengHei" panose="020B0604030504040204" pitchFamily="34" charset="-120"/>
+              </a:defRPr>
+            </a:lvl5pPr>
+          </a:lstStyle>
           <a:p>
             <a:pPr lvl="0"/>
             <a:r>
-              <a:rPr lang="en-US" altLang="zh-TW"/>
+              <a:rPr lang="en-US" altLang="zh-TW" dirty="0"/>
               <a:t>Click to edit Master text styles</a:t>
             </a:r>
           </a:p>
           <a:p>
             <a:pPr lvl="1"/>
             <a:r>
-              <a:rPr lang="en-US" altLang="zh-TW"/>
+              <a:rPr lang="en-US" altLang="zh-TW" dirty="0"/>
               <a:t>Second level</a:t>
             </a:r>
           </a:p>
           <a:p>
             <a:pPr lvl="2"/>
             <a:r>
-              <a:rPr lang="en-US" altLang="zh-TW"/>
+              <a:rPr lang="en-US" altLang="zh-TW" dirty="0"/>
               <a:t>Third level</a:t>
             </a:r>
           </a:p>
           <a:p>
             <a:pPr lvl="3"/>
             <a:r>
-              <a:rPr lang="en-US" altLang="zh-TW"/>
+              <a:rPr lang="en-US" altLang="zh-TW" dirty="0"/>
               <a:t>Fourth level</a:t>
             </a:r>
           </a:p>
           <a:p>
             <a:pPr lvl="4"/>
             <a:r>
-              <a:rPr lang="en-US" altLang="zh-TW"/>
+              <a:rPr lang="en-US" altLang="zh-TW" dirty="0"/>
               <a:t>Fifth level</a:t>
             </a:r>
             <a:endParaRPr lang="en-TW" dirty="0"/>
@@ -3111,7 +3142,38 @@
         </p:spPr>
         <p:txBody>
           <a:bodyPr/>
-          <a:lstStyle/>
+          <a:lstStyle>
+            <a:lvl1pPr>
+              <a:defRPr baseline="0">
+                <a:latin typeface="Arial" panose="020B0604020202020204" pitchFamily="34" charset="0"/>
+                <a:ea typeface="Microsoft JhengHei" panose="020B0604030504040204" pitchFamily="34" charset="-120"/>
+              </a:defRPr>
+            </a:lvl1pPr>
+            <a:lvl2pPr>
+              <a:defRPr baseline="0">
+                <a:latin typeface="Arial" panose="020B0604020202020204" pitchFamily="34" charset="0"/>
+                <a:ea typeface="Microsoft JhengHei" panose="020B0604030504040204" pitchFamily="34" charset="-120"/>
+              </a:defRPr>
+            </a:lvl2pPr>
+            <a:lvl3pPr>
+              <a:defRPr baseline="0">
+                <a:latin typeface="Arial" panose="020B0604020202020204" pitchFamily="34" charset="0"/>
+                <a:ea typeface="Microsoft JhengHei" panose="020B0604030504040204" pitchFamily="34" charset="-120"/>
+              </a:defRPr>
+            </a:lvl3pPr>
+            <a:lvl4pPr>
+              <a:defRPr baseline="0">
+                <a:latin typeface="Arial" panose="020B0604020202020204" pitchFamily="34" charset="0"/>
+                <a:ea typeface="Microsoft JhengHei" panose="020B0604030504040204" pitchFamily="34" charset="-120"/>
+              </a:defRPr>
+            </a:lvl4pPr>
+            <a:lvl5pPr>
+              <a:defRPr baseline="0">
+                <a:latin typeface="Arial" panose="020B0604020202020204" pitchFamily="34" charset="0"/>
+                <a:ea typeface="Microsoft JhengHei" panose="020B0604030504040204" pitchFamily="34" charset="-120"/>
+              </a:defRPr>
+            </a:lvl5pPr>
+          </a:lstStyle>
           <a:p>
             <a:pPr lvl="0"/>
             <a:r>
@@ -3195,7 +3257,10 @@
           <a:p>
             <a:pPr algn="ctr"/>
             <a:r>
-              <a:rPr lang="en-TW" dirty="0"/>
+              <a:rPr lang="en-TW" baseline="0" dirty="0">
+                <a:latin typeface="Arial" panose="020B0604020202020204" pitchFamily="34" charset="0"/>
+                <a:ea typeface="Microsoft JhengHei" panose="020B0604030504040204" pitchFamily="34" charset="-120"/>
+              </a:rPr>
               <a:t>Source</a:t>
             </a:r>
           </a:p>
@@ -3246,7 +3311,10 @@
           <a:p>
             <a:pPr algn="ctr"/>
             <a:r>
-              <a:rPr lang="en-TW" dirty="0"/>
+              <a:rPr lang="en-TW" baseline="0" dirty="0">
+                <a:latin typeface="Arial" panose="020B0604020202020204" pitchFamily="34" charset="0"/>
+                <a:ea typeface="Microsoft JhengHei" panose="020B0604030504040204" pitchFamily="34" charset="-120"/>
+              </a:rPr>
               <a:t>Gen</a:t>
             </a:r>
           </a:p>
@@ -3284,10 +3352,12 @@
           <a:lstStyle>
             <a:lvl1pPr marL="0" indent="0" algn="ctr">
               <a:buNone/>
-              <a:defRPr sz="1800">
+              <a:defRPr sz="1800" baseline="0">
                 <a:solidFill>
                   <a:srgbClr val="FF0000"/>
                 </a:solidFill>
+                <a:latin typeface="Arial" panose="020B0604020202020204" pitchFamily="34" charset="0"/>
+                <a:ea typeface="Microsoft JhengHei" panose="020B0604030504040204" pitchFamily="34" charset="-120"/>
               </a:defRPr>
             </a:lvl1pPr>
           </a:lstStyle>
@@ -3776,7 +3846,7 @@
           <a:p>
             <a:fld id="{1B18B556-6596-E04A-9A94-BF47DB4EF23C}" type="datetimeFigureOut">
               <a:rPr lang="en-TW" smtClean="0"/>
-              <a:t>2026/1/27</a:t>
+              <a:t>2026/2/5</a:t>
             </a:fld>
             <a:endParaRPr lang="en-TW"/>
           </a:p>
@@ -4019,7 +4089,7 @@
           <a:p>
             <a:fld id="{1B18B556-6596-E04A-9A94-BF47DB4EF23C}" type="datetimeFigureOut">
               <a:rPr lang="en-TW" smtClean="0"/>
-              <a:t>2026/1/27</a:t>
+              <a:t>2026/2/5</a:t>
             </a:fld>
             <a:endParaRPr lang="en-TW"/>
           </a:p>
@@ -5132,7 +5202,7 @@
           <a:bodyPr/>
           <a:lstStyle/>
           <a:p>
-            <a:endParaRPr lang="en-TW"/>
+            <a:endParaRPr lang="en-TW" dirty="0"/>
           </a:p>
         </p:txBody>
       </p:sp>
@@ -5157,7 +5227,7 @@
           <a:bodyPr/>
           <a:lstStyle/>
           <a:p>
-            <a:endParaRPr lang="en-TW"/>
+            <a:endParaRPr lang="en-TW" dirty="0"/>
           </a:p>
         </p:txBody>
       </p:sp>

</xml_diff>